<commit_message>
docs: include relevant sustainable development goals
</commit_message>
<xml_diff>
--- a/docs/ProjectPulse-Presentation.pptx
+++ b/docs/ProjectPulse-Presentation.pptx
@@ -2,26 +2,27 @@
 <file path=ppt/presentation.xml><?xml version="1.0" encoding="utf-8"?>
 <p:presentation xmlns:p="http://schemas.openxmlformats.org/presentationml/2006/main">
   <p:sldMasterIdLst>
-    <p:sldMasterId xmlns:r="http://schemas.openxmlformats.org/officeDocument/2006/relationships" id="2147483648" r:id="R41b542010b5d4243"/>
+    <p:sldMasterId xmlns:r="http://schemas.openxmlformats.org/officeDocument/2006/relationships" id="2147483648" r:id="Rb6ae9d860ee74ab1"/>
   </p:sldMasterIdLst>
   <p:notesMasterIdLst>
-    <p:notesMasterId xmlns:r="http://schemas.openxmlformats.org/officeDocument/2006/relationships" r:id="R573f3c7931dd4116"/>
+    <p:notesMasterId xmlns:r="http://schemas.openxmlformats.org/officeDocument/2006/relationships" r:id="Rc4a0cb5ae9de41af"/>
   </p:notesMasterIdLst>
   <p:sldIdLst>
-    <p:sldId xmlns:r="http://schemas.openxmlformats.org/officeDocument/2006/relationships" id="256" r:id="Rde42664bd4ec4ed7"/>
-    <p:sldId xmlns:r="http://schemas.openxmlformats.org/officeDocument/2006/relationships" id="257" r:id="R0965ce02a7c54610"/>
-    <p:sldId xmlns:r="http://schemas.openxmlformats.org/officeDocument/2006/relationships" id="258" r:id="Rd63eab7189af46d7"/>
-    <p:sldId xmlns:r="http://schemas.openxmlformats.org/officeDocument/2006/relationships" id="259" r:id="R4f9403d09d7047a3"/>
-    <p:sldId xmlns:r="http://schemas.openxmlformats.org/officeDocument/2006/relationships" id="260" r:id="R2e5dc402fd354744"/>
-    <p:sldId xmlns:r="http://schemas.openxmlformats.org/officeDocument/2006/relationships" id="261" r:id="R63e48e0c2e8543cf"/>
-    <p:sldId xmlns:r="http://schemas.openxmlformats.org/officeDocument/2006/relationships" id="262" r:id="Reaa99b72ffe1463a"/>
-    <p:sldId xmlns:r="http://schemas.openxmlformats.org/officeDocument/2006/relationships" id="263" r:id="Rda74fa298393455a"/>
-    <p:sldId xmlns:r="http://schemas.openxmlformats.org/officeDocument/2006/relationships" id="264" r:id="R88618ca951c74e68"/>
-    <p:sldId xmlns:r="http://schemas.openxmlformats.org/officeDocument/2006/relationships" id="265" r:id="Rab8f320981204cd5"/>
-    <p:sldId xmlns:r="http://schemas.openxmlformats.org/officeDocument/2006/relationships" id="266" r:id="R5a6bebc8ca294515"/>
-    <p:sldId xmlns:r="http://schemas.openxmlformats.org/officeDocument/2006/relationships" id="267" r:id="R595f33838bf94a99"/>
-    <p:sldId xmlns:r="http://schemas.openxmlformats.org/officeDocument/2006/relationships" id="268" r:id="Rc84571dde4224eb0"/>
-    <p:sldId xmlns:r="http://schemas.openxmlformats.org/officeDocument/2006/relationships" id="269" r:id="R2f24df7574384f5e"/>
+    <p:sldId xmlns:r="http://schemas.openxmlformats.org/officeDocument/2006/relationships" id="256" r:id="R168201cabde54a8b"/>
+    <p:sldId xmlns:r="http://schemas.openxmlformats.org/officeDocument/2006/relationships" id="257" r:id="R966e55cb09964bca"/>
+    <p:sldId xmlns:r="http://schemas.openxmlformats.org/officeDocument/2006/relationships" id="258" r:id="Ra3e65e8deb5b40e1"/>
+    <p:sldId xmlns:r="http://schemas.openxmlformats.org/officeDocument/2006/relationships" id="259" r:id="R0171d38de5fe41ec"/>
+    <p:sldId xmlns:r="http://schemas.openxmlformats.org/officeDocument/2006/relationships" id="260" r:id="R097f322fd4c3453a"/>
+    <p:sldId xmlns:r="http://schemas.openxmlformats.org/officeDocument/2006/relationships" id="261" r:id="R2fdc1caabe664992"/>
+    <p:sldId xmlns:r="http://schemas.openxmlformats.org/officeDocument/2006/relationships" id="262" r:id="R1e03165e58ad4e84"/>
+    <p:sldId xmlns:r="http://schemas.openxmlformats.org/officeDocument/2006/relationships" id="263" r:id="R69afbb434c4a45f2"/>
+    <p:sldId xmlns:r="http://schemas.openxmlformats.org/officeDocument/2006/relationships" id="264" r:id="Re94e784e7ab14463"/>
+    <p:sldId xmlns:r="http://schemas.openxmlformats.org/officeDocument/2006/relationships" id="265" r:id="Ra7cd14ff69f4499f"/>
+    <p:sldId xmlns:r="http://schemas.openxmlformats.org/officeDocument/2006/relationships" id="266" r:id="R923165e92c53479f"/>
+    <p:sldId xmlns:r="http://schemas.openxmlformats.org/officeDocument/2006/relationships" id="267" r:id="R03cd8a8808fa40f2"/>
+    <p:sldId xmlns:r="http://schemas.openxmlformats.org/officeDocument/2006/relationships" id="268" r:id="R0f711ab1d17347aa"/>
+    <p:sldId xmlns:r="http://schemas.openxmlformats.org/officeDocument/2006/relationships" id="269" r:id="Rc337ee9f37b04c2a"/>
+    <p:sldId xmlns:r="http://schemas.openxmlformats.org/officeDocument/2006/relationships" id="270" r:id="Rba0ee076d66e49fd"/>
   </p:sldIdLst>
   <p:sldSz cx="12192000" cy="6858000"/>
   <p:notesSz cx="6858000" cy="9144000"/>
@@ -665,7 +666,7 @@
           <a:lstStyle xmlns:a="http://schemas.openxmlformats.org/drawingml/2006/main"/>
           <a:p xmlns:a="http://schemas.openxmlformats.org/drawingml/2006/main">
             <a:r>
-              <a:t>All project reads and changes enforce organization membership and roles on the server. Session mutations require CSRF. Project and calendar edits use version checks to reject stale saves. Feature cleanup retains migrations, legacy tables and minimal ORM mappings for existing records. Explicit user deletion still follows normal cascade semantics. Source: docs/architecture.md and docs/api-conventions.md.</a:t>
+              <a:t>The United Nations describes Goal 8 as promoting sustained, inclusive and sustainable economic growth, full and productive employment and decent work for all. Target 8.3 includes support for productive activities, entrepreneurship and growth of micro, small and medium-sized enterprises. Goal 9 focuses on resilient infrastructure, sustainable industrialization and innovation. ProjectPulse is relevant as a planning tool used for a fictional small-business website project. These links are a reasoned alignment, not evidence that the project achieved SDG outcomes. Sources: UN Goal 8, https://sdgs.un.org/goals/goal8 ; UN Goal 9, https://sdgs.un.org/goals/goal9</a:t>
             </a:r>
           </a:p>
         </p:txBody>
@@ -735,6 +736,76 @@
           <a:lstStyle xmlns:a="http://schemas.openxmlformats.org/drawingml/2006/main"/>
           <a:p xmlns:a="http://schemas.openxmlformats.org/drawingml/2006/main">
             <a:r>
+              <a:t>All project reads and changes enforce organization membership and roles on the server. Session mutations require CSRF. Project and calendar edits use version checks to reject stale saves. Feature cleanup retains migrations, legacy tables and minimal ORM mappings for existing records. Explicit user deletion still follows normal cascade semantics. Source: docs/architecture.md and docs/api-conventions.md.</a:t>
+            </a:r>
+          </a:p>
+        </p:txBody>
+      </p:sp>
+      <p:sp>
+        <p:nvSpPr>
+          <p:cNvPr id="4" name="Slide Number Placeholder 3"/>
+          <p:cNvSpPr>
+            <a:spLocks xmlns:a="http://schemas.openxmlformats.org/drawingml/2006/main" noGrp="1"/>
+          </p:cNvSpPr>
+          <p:nvPr>
+            <p:ph type="sldNum" idx="5"/>
+          </p:nvPr>
+        </p:nvSpPr>
+        <p:spPr/>
+        <p:txBody>
+          <a:bodyPr xmlns:a="http://schemas.openxmlformats.org/drawingml/2006/main"/>
+          <a:lstStyle xmlns:a="http://schemas.openxmlformats.org/drawingml/2006/main"/>
+          <a:p xmlns:a="http://schemas.openxmlformats.org/drawingml/2006/main"/>
+        </p:txBody>
+      </p:sp>
+    </p:spTree>
+  </p:cSld>
+  <p:clrMapOvr>
+    <a:masterClrMapping xmlns:a="http://schemas.openxmlformats.org/drawingml/2006/main"/>
+  </p:clrMapOvr>
+</p:notes>
+</file>
+
+<file path=ppt/notesSlides/notesSlide14.xml><?xml version="1.0" encoding="utf-8"?>
+<p:notes xmlns:p="http://schemas.openxmlformats.org/presentationml/2006/main">
+  <p:cSld>
+    <p:spTree>
+      <p:nvGrpSpPr>
+        <p:cNvPr id="1" name=""/>
+        <p:cNvGrpSpPr/>
+        <p:nvPr/>
+      </p:nvGrpSpPr>
+      <p:grpSpPr>
+        <a:xfrm xmlns:a="http://schemas.openxmlformats.org/drawingml/2006/main"/>
+      </p:grpSpPr>
+      <p:sp>
+        <p:nvSpPr>
+          <p:cNvPr id="2" name="Slide Image Placeholder 1"/>
+          <p:cNvSpPr>
+            <a:spLocks xmlns:a="http://schemas.openxmlformats.org/drawingml/2006/main" noGrp="1"/>
+          </p:cNvSpPr>
+          <p:nvPr>
+            <p:ph type="sldImg" idx="0"/>
+          </p:nvPr>
+        </p:nvSpPr>
+        <p:spPr/>
+      </p:sp>
+      <p:sp>
+        <p:nvSpPr>
+          <p:cNvPr id="3" name="Notes Placeholder 2"/>
+          <p:cNvSpPr>
+            <a:spLocks xmlns:a="http://schemas.openxmlformats.org/drawingml/2006/main" noGrp="1"/>
+          </p:cNvSpPr>
+          <p:nvPr>
+            <p:ph type="body" idx="1"/>
+          </p:nvPr>
+        </p:nvSpPr>
+        <p:spPr/>
+        <p:txBody>
+          <a:bodyPr xmlns:a="http://schemas.openxmlformats.org/drawingml/2006/main"/>
+          <a:lstStyle xmlns:a="http://schemas.openxmlformats.org/drawingml/2006/main"/>
+          <a:p xmlns:a="http://schemas.openxmlformats.org/drawingml/2006/main">
+            <a:r>
               <a:t>Recorded verification on 27 October 2026: 101 backend tests and 61 frontend tests passed, along with the production build and disposable-database migration checks. Browser checks covered responsive layouts, light/dark appearance, dialogs, errors and summary refresh. These are engineering checks, not a human user study or production certification. Source: docs/evaluation.md.</a:t>
             </a:r>
           </a:p>
@@ -765,7 +836,7 @@
 </p:notes>
 </file>
 
-<file path=ppt/notesSlides/notesSlide14.xml><?xml version="1.0" encoding="utf-8"?>
+<file path=ppt/notesSlides/notesSlide15.xml><?xml version="1.0" encoding="utf-8"?>
 <p:notes xmlns:p="http://schemas.openxmlformats.org/presentationml/2006/main">
   <p:cSld>
     <p:spTree>
@@ -3808,12 +3879,12 @@
   </p:cSld>
   <p:clrMap bg1="lt1" tx1="dk1" bg2="lt2" tx2="dk2" accent1="accent1" accent2="accent2" accent3="accent3" accent4="accent4" accent5="accent5" accent6="accent6" hlink="hlink" folHlink="folHlink"/>
   <p:sldLayoutIdLst>
-    <p:sldLayoutId xmlns:r="http://schemas.openxmlformats.org/officeDocument/2006/relationships" id="2147483649" r:id="R9fd0a36e1e854d50"/>
-    <p:sldLayoutId xmlns:r="http://schemas.openxmlformats.org/officeDocument/2006/relationships" id="2147483650" r:id="R5bc5cd87aae74a80"/>
-    <p:sldLayoutId xmlns:r="http://schemas.openxmlformats.org/officeDocument/2006/relationships" id="2147483651" r:id="R55878d49a6a4483e"/>
-    <p:sldLayoutId xmlns:r="http://schemas.openxmlformats.org/officeDocument/2006/relationships" id="2147483652" r:id="R19c7acfededb4f9a"/>
-    <p:sldLayoutId xmlns:r="http://schemas.openxmlformats.org/officeDocument/2006/relationships" id="2147483653" r:id="Rf8f8cd53db3c44bf"/>
-    <p:sldLayoutId xmlns:r="http://schemas.openxmlformats.org/officeDocument/2006/relationships" id="2147483654" r:id="R1fd4d74312e24a7d"/>
+    <p:sldLayoutId xmlns:r="http://schemas.openxmlformats.org/officeDocument/2006/relationships" id="2147483649" r:id="R1622c393bf77426e"/>
+    <p:sldLayoutId xmlns:r="http://schemas.openxmlformats.org/officeDocument/2006/relationships" id="2147483650" r:id="R54f7732c06ce485f"/>
+    <p:sldLayoutId xmlns:r="http://schemas.openxmlformats.org/officeDocument/2006/relationships" id="2147483651" r:id="Rc32720359b014fba"/>
+    <p:sldLayoutId xmlns:r="http://schemas.openxmlformats.org/officeDocument/2006/relationships" id="2147483652" r:id="R37fde3573f294b7e"/>
+    <p:sldLayoutId xmlns:r="http://schemas.openxmlformats.org/officeDocument/2006/relationships" id="2147483653" r:id="R4780bd6bd0104140"/>
+    <p:sldLayoutId xmlns:r="http://schemas.openxmlformats.org/officeDocument/2006/relationships" id="2147483654" r:id="Rab066ebb88214f39"/>
   </p:sldLayoutIdLst>
   <p:txStyles>
     <p:titleStyle>
@@ -5504,7 +5575,7 @@
         </p:xfrm>
         <a:graphic xmlns:a="http://schemas.openxmlformats.org/drawingml/2006/main">
           <a:graphicData uri="http://schemas.openxmlformats.org/drawingml/2006/chart">
-            <c:chart xmlns:r="http://schemas.openxmlformats.org/officeDocument/2006/relationships" xmlns:c="http://schemas.openxmlformats.org/drawingml/2006/chart" r:id="R40849c11f7af4ccb"/>
+            <c:chart xmlns:r="http://schemas.openxmlformats.org/officeDocument/2006/relationships" xmlns:c="http://schemas.openxmlformats.org/drawingml/2006/chart" r:id="R7607d598d6aa442d"/>
           </a:graphicData>
         </a:graphic>
       </p:graphicFrame>
@@ -7957,6 +8028,1439 @@
           <p:cNvPr id="2" name="">
             <a:extLst xmlns:a="http://schemas.openxmlformats.org/drawingml/2006/main">
               <a:ext uri="{FF2B5EF4-FFF2-40B4-BE49-F238E27FC236}">
+                <a16:creationId xmlns:a16="http://schemas.microsoft.com/office/drawing/2014/main" id="{52EAC23C-B175-46C1-99C3-AE1BB1F00CE6}"/>
+              </a:ext>
+            </a:extLst>
+          </p:cNvPr>
+          <p:cNvSpPr>
+            <a:spLocks xmlns:a="http://schemas.openxmlformats.org/drawingml/2006/main" noGrp="1"/>
+          </p:cNvSpPr>
+          <p:nvPr/>
+        </p:nvSpPr>
+        <p:spPr>
+          <a:xfrm xmlns:a="http://schemas.openxmlformats.org/drawingml/2006/main">
+            <a:off x="609600" y="400050"/>
+            <a:ext cx="10972800" cy="762000"/>
+          </a:xfrm>
+          <a:prstGeom xmlns:a="http://schemas.openxmlformats.org/drawingml/2006/main" prst="rect">
+            <a:avLst/>
+          </a:prstGeom>
+          <a:noFill xmlns:a="http://schemas.openxmlformats.org/drawingml/2006/main"/>
+          <a:ln xmlns:a="http://schemas.openxmlformats.org/drawingml/2006/main" w="0">
+            <a:noFill/>
+          </a:ln>
+        </p:spPr>
+        <p:txBody>
+          <a:bodyPr xmlns:a="http://schemas.openxmlformats.org/drawingml/2006/main"/>
+          <a:lstStyle xmlns:a="http://schemas.openxmlformats.org/drawingml/2006/main">
+            <a:defPPr>
+              <a:defRPr sz="3300" b="1">
+                <a:solidFill>
+                  <a:srgbClr val="17202B"/>
+                </a:solidFill>
+                <a:latin typeface="Arial"/>
+                <a:ea typeface="Arial"/>
+                <a:cs typeface="Arial"/>
+              </a:defRPr>
+            </a:defPPr>
+            <a:lvl1pPr>
+              <a:defRPr sz="3300" b="1">
+                <a:solidFill>
+                  <a:srgbClr val="17202B"/>
+                </a:solidFill>
+                <a:latin typeface="Arial"/>
+                <a:ea typeface="Arial"/>
+                <a:cs typeface="Arial"/>
+              </a:defRPr>
+            </a:lvl1pPr>
+            <a:lvl2pPr>
+              <a:defRPr sz="3300" b="1">
+                <a:solidFill>
+                  <a:srgbClr val="17202B"/>
+                </a:solidFill>
+                <a:latin typeface="Arial"/>
+                <a:ea typeface="Arial"/>
+                <a:cs typeface="Arial"/>
+              </a:defRPr>
+            </a:lvl2pPr>
+            <a:lvl3pPr>
+              <a:defRPr sz="3300" b="1">
+                <a:solidFill>
+                  <a:srgbClr val="17202B"/>
+                </a:solidFill>
+                <a:latin typeface="Arial"/>
+                <a:ea typeface="Arial"/>
+                <a:cs typeface="Arial"/>
+              </a:defRPr>
+            </a:lvl3pPr>
+            <a:lvl4pPr>
+              <a:defRPr sz="3300" b="1">
+                <a:solidFill>
+                  <a:srgbClr val="17202B"/>
+                </a:solidFill>
+                <a:latin typeface="Arial"/>
+                <a:ea typeface="Arial"/>
+                <a:cs typeface="Arial"/>
+              </a:defRPr>
+            </a:lvl4pPr>
+            <a:lvl5pPr>
+              <a:defRPr sz="3300" b="1">
+                <a:solidFill>
+                  <a:srgbClr val="17202B"/>
+                </a:solidFill>
+                <a:latin typeface="Arial"/>
+                <a:ea typeface="Arial"/>
+                <a:cs typeface="Arial"/>
+              </a:defRPr>
+            </a:lvl5pPr>
+            <a:lvl6pPr>
+              <a:defRPr sz="3300" b="1">
+                <a:solidFill>
+                  <a:srgbClr val="17202B"/>
+                </a:solidFill>
+                <a:latin typeface="Arial"/>
+                <a:ea typeface="Arial"/>
+                <a:cs typeface="Arial"/>
+              </a:defRPr>
+            </a:lvl6pPr>
+            <a:lvl7pPr>
+              <a:defRPr sz="3300" b="1">
+                <a:solidFill>
+                  <a:srgbClr val="17202B"/>
+                </a:solidFill>
+                <a:latin typeface="Arial"/>
+                <a:ea typeface="Arial"/>
+                <a:cs typeface="Arial"/>
+              </a:defRPr>
+            </a:lvl7pPr>
+            <a:lvl8pPr>
+              <a:defRPr sz="3300" b="1">
+                <a:solidFill>
+                  <a:srgbClr val="17202B"/>
+                </a:solidFill>
+                <a:latin typeface="Arial"/>
+                <a:ea typeface="Arial"/>
+                <a:cs typeface="Arial"/>
+              </a:defRPr>
+            </a:lvl8pPr>
+            <a:lvl9pPr>
+              <a:defRPr sz="3300" b="1">
+                <a:solidFill>
+                  <a:srgbClr val="17202B"/>
+                </a:solidFill>
+                <a:latin typeface="Arial"/>
+                <a:ea typeface="Arial"/>
+                <a:cs typeface="Arial"/>
+              </a:defRPr>
+            </a:lvl9pPr>
+          </a:lstStyle>
+          <a:p xmlns:a="http://schemas.openxmlformats.org/drawingml/2006/main">
+            <a:pPr>
+              <a:defRPr sz="3300" b="1">
+                <a:solidFill>
+                  <a:srgbClr val="17202B"/>
+                </a:solidFill>
+                <a:latin typeface="Arial"/>
+                <a:ea typeface="Arial"/>
+                <a:cs typeface="Arial"/>
+              </a:defRPr>
+            </a:pPr>
+            <a:r>
+              <a:rPr sz="3300" b="1">
+                <a:solidFill>
+                  <a:srgbClr val="17202B"/>
+                </a:solidFill>
+                <a:latin typeface="Arial"/>
+                <a:ea typeface="Arial"/>
+                <a:cs typeface="Arial"/>
+              </a:rPr>
+              <a:t>Relevant UN Sustainable Development Goals</a:t>
+            </a:r>
+          </a:p>
+        </p:txBody>
+      </p:sp>
+      <p:sp>
+        <p:nvSpPr>
+          <p:cNvPr id="3" name="">
+            <a:extLst xmlns:a="http://schemas.openxmlformats.org/drawingml/2006/main">
+              <a:ext uri="{FF2B5EF4-FFF2-40B4-BE49-F238E27FC236}">
+                <a16:creationId xmlns:a16="http://schemas.microsoft.com/office/drawing/2014/main" id="{7AB1F7AE-04B5-493E-8401-0B98D9F9CB10}"/>
+              </a:ext>
+            </a:extLst>
+          </p:cNvPr>
+          <p:cNvSpPr>
+            <a:spLocks xmlns:a="http://schemas.openxmlformats.org/drawingml/2006/main" noGrp="1"/>
+          </p:cNvSpPr>
+          <p:nvPr/>
+        </p:nvSpPr>
+        <p:spPr>
+          <a:xfrm xmlns:a="http://schemas.openxmlformats.org/drawingml/2006/main">
+            <a:off x="609600" y="1104900"/>
+            <a:ext cx="10972800" cy="438150"/>
+          </a:xfrm>
+          <a:prstGeom xmlns:a="http://schemas.openxmlformats.org/drawingml/2006/main" prst="rect">
+            <a:avLst/>
+          </a:prstGeom>
+          <a:noFill xmlns:a="http://schemas.openxmlformats.org/drawingml/2006/main"/>
+          <a:ln xmlns:a="http://schemas.openxmlformats.org/drawingml/2006/main" w="0">
+            <a:noFill/>
+          </a:ln>
+        </p:spPr>
+        <p:txBody>
+          <a:bodyPr xmlns:a="http://schemas.openxmlformats.org/drawingml/2006/main"/>
+          <a:lstStyle xmlns:a="http://schemas.openxmlformats.org/drawingml/2006/main">
+            <a:defPPr>
+              <a:defRPr sz="1875" b="0">
+                <a:solidFill>
+                  <a:srgbClr val="596574"/>
+                </a:solidFill>
+                <a:latin typeface="Arial"/>
+                <a:ea typeface="Arial"/>
+                <a:cs typeface="Arial"/>
+              </a:defRPr>
+            </a:defPPr>
+            <a:lvl1pPr>
+              <a:defRPr sz="1875" b="0">
+                <a:solidFill>
+                  <a:srgbClr val="596574"/>
+                </a:solidFill>
+                <a:latin typeface="Arial"/>
+                <a:ea typeface="Arial"/>
+                <a:cs typeface="Arial"/>
+              </a:defRPr>
+            </a:lvl1pPr>
+            <a:lvl2pPr>
+              <a:defRPr sz="1875" b="0">
+                <a:solidFill>
+                  <a:srgbClr val="596574"/>
+                </a:solidFill>
+                <a:latin typeface="Arial"/>
+                <a:ea typeface="Arial"/>
+                <a:cs typeface="Arial"/>
+              </a:defRPr>
+            </a:lvl2pPr>
+            <a:lvl3pPr>
+              <a:defRPr sz="1875" b="0">
+                <a:solidFill>
+                  <a:srgbClr val="596574"/>
+                </a:solidFill>
+                <a:latin typeface="Arial"/>
+                <a:ea typeface="Arial"/>
+                <a:cs typeface="Arial"/>
+              </a:defRPr>
+            </a:lvl3pPr>
+            <a:lvl4pPr>
+              <a:defRPr sz="1875" b="0">
+                <a:solidFill>
+                  <a:srgbClr val="596574"/>
+                </a:solidFill>
+                <a:latin typeface="Arial"/>
+                <a:ea typeface="Arial"/>
+                <a:cs typeface="Arial"/>
+              </a:defRPr>
+            </a:lvl4pPr>
+            <a:lvl5pPr>
+              <a:defRPr sz="1875" b="0">
+                <a:solidFill>
+                  <a:srgbClr val="596574"/>
+                </a:solidFill>
+                <a:latin typeface="Arial"/>
+                <a:ea typeface="Arial"/>
+                <a:cs typeface="Arial"/>
+              </a:defRPr>
+            </a:lvl5pPr>
+            <a:lvl6pPr>
+              <a:defRPr sz="1875" b="0">
+                <a:solidFill>
+                  <a:srgbClr val="596574"/>
+                </a:solidFill>
+                <a:latin typeface="Arial"/>
+                <a:ea typeface="Arial"/>
+                <a:cs typeface="Arial"/>
+              </a:defRPr>
+            </a:lvl6pPr>
+            <a:lvl7pPr>
+              <a:defRPr sz="1875" b="0">
+                <a:solidFill>
+                  <a:srgbClr val="596574"/>
+                </a:solidFill>
+                <a:latin typeface="Arial"/>
+                <a:ea typeface="Arial"/>
+                <a:cs typeface="Arial"/>
+              </a:defRPr>
+            </a:lvl7pPr>
+            <a:lvl8pPr>
+              <a:defRPr sz="1875" b="0">
+                <a:solidFill>
+                  <a:srgbClr val="596574"/>
+                </a:solidFill>
+                <a:latin typeface="Arial"/>
+                <a:ea typeface="Arial"/>
+                <a:cs typeface="Arial"/>
+              </a:defRPr>
+            </a:lvl8pPr>
+            <a:lvl9pPr>
+              <a:defRPr sz="1875" b="0">
+                <a:solidFill>
+                  <a:srgbClr val="596574"/>
+                </a:solidFill>
+                <a:latin typeface="Arial"/>
+                <a:ea typeface="Arial"/>
+                <a:cs typeface="Arial"/>
+              </a:defRPr>
+            </a:lvl9pPr>
+          </a:lstStyle>
+          <a:p xmlns:a="http://schemas.openxmlformats.org/drawingml/2006/main">
+            <a:pPr>
+              <a:defRPr sz="1875" b="0">
+                <a:solidFill>
+                  <a:srgbClr val="596574"/>
+                </a:solidFill>
+                <a:latin typeface="Arial"/>
+                <a:ea typeface="Arial"/>
+                <a:cs typeface="Arial"/>
+              </a:defRPr>
+            </a:pPr>
+            <a:r>
+              <a:rPr sz="1875" b="0">
+                <a:solidFill>
+                  <a:srgbClr val="596574"/>
+                </a:solidFill>
+                <a:latin typeface="Arial"/>
+                <a:ea typeface="Arial"/>
+                <a:cs typeface="Arial"/>
+              </a:rPr>
+              <a:t>Potential alignment through the sample project and the planning tool</a:t>
+            </a:r>
+          </a:p>
+        </p:txBody>
+      </p:sp>
+      <p:sp>
+        <p:nvSpPr>
+          <p:cNvPr id="4" name="">
+            <a:extLst xmlns:a="http://schemas.openxmlformats.org/drawingml/2006/main">
+              <a:ext uri="{FF2B5EF4-FFF2-40B4-BE49-F238E27FC236}">
+                <a16:creationId xmlns:a16="http://schemas.microsoft.com/office/drawing/2014/main" id="{B84BEC59-35C3-4C74-B99B-6CF113262553}"/>
+              </a:ext>
+            </a:extLst>
+          </p:cNvPr>
+          <p:cNvSpPr>
+            <a:spLocks xmlns:a="http://schemas.openxmlformats.org/drawingml/2006/main" noGrp="1"/>
+          </p:cNvSpPr>
+          <p:nvPr/>
+        </p:nvSpPr>
+        <p:spPr>
+          <a:xfrm xmlns:a="http://schemas.openxmlformats.org/drawingml/2006/main">
+            <a:off x="685800" y="1952625"/>
+            <a:ext cx="4476750" cy="685800"/>
+          </a:xfrm>
+          <a:prstGeom xmlns:a="http://schemas.openxmlformats.org/drawingml/2006/main" prst="rect">
+            <a:avLst/>
+          </a:prstGeom>
+          <a:noFill xmlns:a="http://schemas.openxmlformats.org/drawingml/2006/main"/>
+          <a:ln xmlns:a="http://schemas.openxmlformats.org/drawingml/2006/main" w="0">
+            <a:noFill/>
+          </a:ln>
+        </p:spPr>
+        <p:txBody>
+          <a:bodyPr xmlns:a="http://schemas.openxmlformats.org/drawingml/2006/main"/>
+          <a:lstStyle xmlns:a="http://schemas.openxmlformats.org/drawingml/2006/main">
+            <a:defPPr>
+              <a:defRPr sz="4200" b="1">
+                <a:solidFill>
+                  <a:srgbClr val="006EDB"/>
+                </a:solidFill>
+                <a:latin typeface="Arial"/>
+                <a:ea typeface="Arial"/>
+                <a:cs typeface="Arial"/>
+              </a:defRPr>
+            </a:defPPr>
+            <a:lvl1pPr>
+              <a:defRPr sz="4200" b="1">
+                <a:solidFill>
+                  <a:srgbClr val="006EDB"/>
+                </a:solidFill>
+                <a:latin typeface="Arial"/>
+                <a:ea typeface="Arial"/>
+                <a:cs typeface="Arial"/>
+              </a:defRPr>
+            </a:lvl1pPr>
+            <a:lvl2pPr>
+              <a:defRPr sz="4200" b="1">
+                <a:solidFill>
+                  <a:srgbClr val="006EDB"/>
+                </a:solidFill>
+                <a:latin typeface="Arial"/>
+                <a:ea typeface="Arial"/>
+                <a:cs typeface="Arial"/>
+              </a:defRPr>
+            </a:lvl2pPr>
+            <a:lvl3pPr>
+              <a:defRPr sz="4200" b="1">
+                <a:solidFill>
+                  <a:srgbClr val="006EDB"/>
+                </a:solidFill>
+                <a:latin typeface="Arial"/>
+                <a:ea typeface="Arial"/>
+                <a:cs typeface="Arial"/>
+              </a:defRPr>
+            </a:lvl3pPr>
+            <a:lvl4pPr>
+              <a:defRPr sz="4200" b="1">
+                <a:solidFill>
+                  <a:srgbClr val="006EDB"/>
+                </a:solidFill>
+                <a:latin typeface="Arial"/>
+                <a:ea typeface="Arial"/>
+                <a:cs typeface="Arial"/>
+              </a:defRPr>
+            </a:lvl4pPr>
+            <a:lvl5pPr>
+              <a:defRPr sz="4200" b="1">
+                <a:solidFill>
+                  <a:srgbClr val="006EDB"/>
+                </a:solidFill>
+                <a:latin typeface="Arial"/>
+                <a:ea typeface="Arial"/>
+                <a:cs typeface="Arial"/>
+              </a:defRPr>
+            </a:lvl5pPr>
+            <a:lvl6pPr>
+              <a:defRPr sz="4200" b="1">
+                <a:solidFill>
+                  <a:srgbClr val="006EDB"/>
+                </a:solidFill>
+                <a:latin typeface="Arial"/>
+                <a:ea typeface="Arial"/>
+                <a:cs typeface="Arial"/>
+              </a:defRPr>
+            </a:lvl6pPr>
+            <a:lvl7pPr>
+              <a:defRPr sz="4200" b="1">
+                <a:solidFill>
+                  <a:srgbClr val="006EDB"/>
+                </a:solidFill>
+                <a:latin typeface="Arial"/>
+                <a:ea typeface="Arial"/>
+                <a:cs typeface="Arial"/>
+              </a:defRPr>
+            </a:lvl7pPr>
+            <a:lvl8pPr>
+              <a:defRPr sz="4200" b="1">
+                <a:solidFill>
+                  <a:srgbClr val="006EDB"/>
+                </a:solidFill>
+                <a:latin typeface="Arial"/>
+                <a:ea typeface="Arial"/>
+                <a:cs typeface="Arial"/>
+              </a:defRPr>
+            </a:lvl8pPr>
+            <a:lvl9pPr>
+              <a:defRPr sz="4200" b="1">
+                <a:solidFill>
+                  <a:srgbClr val="006EDB"/>
+                </a:solidFill>
+                <a:latin typeface="Arial"/>
+                <a:ea typeface="Arial"/>
+                <a:cs typeface="Arial"/>
+              </a:defRPr>
+            </a:lvl9pPr>
+          </a:lstStyle>
+          <a:p xmlns:a="http://schemas.openxmlformats.org/drawingml/2006/main">
+            <a:pPr>
+              <a:defRPr sz="4200" b="1">
+                <a:solidFill>
+                  <a:srgbClr val="006EDB"/>
+                </a:solidFill>
+                <a:latin typeface="Arial"/>
+                <a:ea typeface="Arial"/>
+                <a:cs typeface="Arial"/>
+              </a:defRPr>
+            </a:pPr>
+            <a:r>
+              <a:rPr sz="4200" b="1">
+                <a:solidFill>
+                  <a:srgbClr val="006EDB"/>
+                </a:solidFill>
+                <a:latin typeface="Arial"/>
+                <a:ea typeface="Arial"/>
+                <a:cs typeface="Arial"/>
+              </a:rPr>
+              <a:t>GOAL 8</a:t>
+            </a:r>
+          </a:p>
+        </p:txBody>
+      </p:sp>
+      <p:sp>
+        <p:nvSpPr>
+          <p:cNvPr id="5" name="">
+            <a:extLst xmlns:a="http://schemas.openxmlformats.org/drawingml/2006/main">
+              <a:ext uri="{FF2B5EF4-FFF2-40B4-BE49-F238E27FC236}">
+                <a16:creationId xmlns:a16="http://schemas.microsoft.com/office/drawing/2014/main" id="{A02883A5-59CA-4FFC-83B2-E461A535A330}"/>
+              </a:ext>
+            </a:extLst>
+          </p:cNvPr>
+          <p:cNvSpPr>
+            <a:spLocks xmlns:a="http://schemas.openxmlformats.org/drawingml/2006/main" noGrp="1"/>
+          </p:cNvSpPr>
+          <p:nvPr/>
+        </p:nvSpPr>
+        <p:spPr>
+          <a:xfrm xmlns:a="http://schemas.openxmlformats.org/drawingml/2006/main">
+            <a:off x="685800" y="2686050"/>
+            <a:ext cx="4762500" cy="714375"/>
+          </a:xfrm>
+          <a:prstGeom xmlns:a="http://schemas.openxmlformats.org/drawingml/2006/main" prst="rect">
+            <a:avLst/>
+          </a:prstGeom>
+          <a:noFill xmlns:a="http://schemas.openxmlformats.org/drawingml/2006/main"/>
+          <a:ln xmlns:a="http://schemas.openxmlformats.org/drawingml/2006/main" w="0">
+            <a:noFill/>
+          </a:ln>
+        </p:spPr>
+        <p:txBody>
+          <a:bodyPr xmlns:a="http://schemas.openxmlformats.org/drawingml/2006/main"/>
+          <a:lstStyle xmlns:a="http://schemas.openxmlformats.org/drawingml/2006/main">
+            <a:defPPr>
+              <a:defRPr sz="2250" b="1">
+                <a:solidFill>
+                  <a:srgbClr val="17202B"/>
+                </a:solidFill>
+                <a:latin typeface="Arial"/>
+                <a:ea typeface="Arial"/>
+                <a:cs typeface="Arial"/>
+              </a:defRPr>
+            </a:defPPr>
+            <a:lvl1pPr>
+              <a:defRPr sz="2250" b="1">
+                <a:solidFill>
+                  <a:srgbClr val="17202B"/>
+                </a:solidFill>
+                <a:latin typeface="Arial"/>
+                <a:ea typeface="Arial"/>
+                <a:cs typeface="Arial"/>
+              </a:defRPr>
+            </a:lvl1pPr>
+            <a:lvl2pPr>
+              <a:defRPr sz="2250" b="1">
+                <a:solidFill>
+                  <a:srgbClr val="17202B"/>
+                </a:solidFill>
+                <a:latin typeface="Arial"/>
+                <a:ea typeface="Arial"/>
+                <a:cs typeface="Arial"/>
+              </a:defRPr>
+            </a:lvl2pPr>
+            <a:lvl3pPr>
+              <a:defRPr sz="2250" b="1">
+                <a:solidFill>
+                  <a:srgbClr val="17202B"/>
+                </a:solidFill>
+                <a:latin typeface="Arial"/>
+                <a:ea typeface="Arial"/>
+                <a:cs typeface="Arial"/>
+              </a:defRPr>
+            </a:lvl3pPr>
+            <a:lvl4pPr>
+              <a:defRPr sz="2250" b="1">
+                <a:solidFill>
+                  <a:srgbClr val="17202B"/>
+                </a:solidFill>
+                <a:latin typeface="Arial"/>
+                <a:ea typeface="Arial"/>
+                <a:cs typeface="Arial"/>
+              </a:defRPr>
+            </a:lvl4pPr>
+            <a:lvl5pPr>
+              <a:defRPr sz="2250" b="1">
+                <a:solidFill>
+                  <a:srgbClr val="17202B"/>
+                </a:solidFill>
+                <a:latin typeface="Arial"/>
+                <a:ea typeface="Arial"/>
+                <a:cs typeface="Arial"/>
+              </a:defRPr>
+            </a:lvl5pPr>
+            <a:lvl6pPr>
+              <a:defRPr sz="2250" b="1">
+                <a:solidFill>
+                  <a:srgbClr val="17202B"/>
+                </a:solidFill>
+                <a:latin typeface="Arial"/>
+                <a:ea typeface="Arial"/>
+                <a:cs typeface="Arial"/>
+              </a:defRPr>
+            </a:lvl6pPr>
+            <a:lvl7pPr>
+              <a:defRPr sz="2250" b="1">
+                <a:solidFill>
+                  <a:srgbClr val="17202B"/>
+                </a:solidFill>
+                <a:latin typeface="Arial"/>
+                <a:ea typeface="Arial"/>
+                <a:cs typeface="Arial"/>
+              </a:defRPr>
+            </a:lvl7pPr>
+            <a:lvl8pPr>
+              <a:defRPr sz="2250" b="1">
+                <a:solidFill>
+                  <a:srgbClr val="17202B"/>
+                </a:solidFill>
+                <a:latin typeface="Arial"/>
+                <a:ea typeface="Arial"/>
+                <a:cs typeface="Arial"/>
+              </a:defRPr>
+            </a:lvl8pPr>
+            <a:lvl9pPr>
+              <a:defRPr sz="2250" b="1">
+                <a:solidFill>
+                  <a:srgbClr val="17202B"/>
+                </a:solidFill>
+                <a:latin typeface="Arial"/>
+                <a:ea typeface="Arial"/>
+                <a:cs typeface="Arial"/>
+              </a:defRPr>
+            </a:lvl9pPr>
+          </a:lstStyle>
+          <a:p xmlns:a="http://schemas.openxmlformats.org/drawingml/2006/main">
+            <a:pPr>
+              <a:defRPr sz="2250" b="1">
+                <a:solidFill>
+                  <a:srgbClr val="17202B"/>
+                </a:solidFill>
+                <a:latin typeface="Arial"/>
+                <a:ea typeface="Arial"/>
+                <a:cs typeface="Arial"/>
+              </a:defRPr>
+            </a:pPr>
+            <a:r>
+              <a:rPr sz="2250" b="1">
+                <a:solidFill>
+                  <a:srgbClr val="17202B"/>
+                </a:solidFill>
+                <a:latin typeface="Arial"/>
+                <a:ea typeface="Arial"/>
+                <a:cs typeface="Arial"/>
+              </a:rPr>
+              <a:t>Decent Work and Economic Growth</a:t>
+            </a:r>
+          </a:p>
+        </p:txBody>
+      </p:sp>
+      <p:sp>
+        <p:nvSpPr>
+          <p:cNvPr id="6" name="">
+            <a:extLst xmlns:a="http://schemas.openxmlformats.org/drawingml/2006/main">
+              <a:ext uri="{FF2B5EF4-FFF2-40B4-BE49-F238E27FC236}">
+                <a16:creationId xmlns:a16="http://schemas.microsoft.com/office/drawing/2014/main" id="{40FFA202-A4B9-41F7-8125-5592F1935B53}"/>
+              </a:ext>
+            </a:extLst>
+          </p:cNvPr>
+          <p:cNvSpPr>
+            <a:spLocks xmlns:a="http://schemas.openxmlformats.org/drawingml/2006/main" noGrp="1"/>
+          </p:cNvSpPr>
+          <p:nvPr/>
+        </p:nvSpPr>
+        <p:spPr>
+          <a:xfrm xmlns:a="http://schemas.openxmlformats.org/drawingml/2006/main">
+            <a:off x="685800" y="3638550"/>
+            <a:ext cx="4762500" cy="1762125"/>
+          </a:xfrm>
+          <a:prstGeom xmlns:a="http://schemas.openxmlformats.org/drawingml/2006/main" prst="rect">
+            <a:avLst/>
+          </a:prstGeom>
+          <a:noFill xmlns:a="http://schemas.openxmlformats.org/drawingml/2006/main"/>
+          <a:ln xmlns:a="http://schemas.openxmlformats.org/drawingml/2006/main" w="0">
+            <a:noFill/>
+          </a:ln>
+        </p:spPr>
+        <p:txBody>
+          <a:bodyPr xmlns:a="http://schemas.openxmlformats.org/drawingml/2006/main"/>
+          <a:lstStyle xmlns:a="http://schemas.openxmlformats.org/drawingml/2006/main">
+            <a:defPPr>
+              <a:defRPr sz="1875" b="0">
+                <a:solidFill>
+                  <a:srgbClr val="17202B"/>
+                </a:solidFill>
+                <a:latin typeface="Arial"/>
+                <a:ea typeface="Arial"/>
+                <a:cs typeface="Arial"/>
+              </a:defRPr>
+            </a:defPPr>
+            <a:lvl1pPr>
+              <a:defRPr sz="1875" b="0">
+                <a:solidFill>
+                  <a:srgbClr val="17202B"/>
+                </a:solidFill>
+                <a:latin typeface="Arial"/>
+                <a:ea typeface="Arial"/>
+                <a:cs typeface="Arial"/>
+              </a:defRPr>
+            </a:lvl1pPr>
+            <a:lvl2pPr>
+              <a:defRPr sz="1875" b="0">
+                <a:solidFill>
+                  <a:srgbClr val="17202B"/>
+                </a:solidFill>
+                <a:latin typeface="Arial"/>
+                <a:ea typeface="Arial"/>
+                <a:cs typeface="Arial"/>
+              </a:defRPr>
+            </a:lvl2pPr>
+            <a:lvl3pPr>
+              <a:defRPr sz="1875" b="0">
+                <a:solidFill>
+                  <a:srgbClr val="17202B"/>
+                </a:solidFill>
+                <a:latin typeface="Arial"/>
+                <a:ea typeface="Arial"/>
+                <a:cs typeface="Arial"/>
+              </a:defRPr>
+            </a:lvl3pPr>
+            <a:lvl4pPr>
+              <a:defRPr sz="1875" b="0">
+                <a:solidFill>
+                  <a:srgbClr val="17202B"/>
+                </a:solidFill>
+                <a:latin typeface="Arial"/>
+                <a:ea typeface="Arial"/>
+                <a:cs typeface="Arial"/>
+              </a:defRPr>
+            </a:lvl4pPr>
+            <a:lvl5pPr>
+              <a:defRPr sz="1875" b="0">
+                <a:solidFill>
+                  <a:srgbClr val="17202B"/>
+                </a:solidFill>
+                <a:latin typeface="Arial"/>
+                <a:ea typeface="Arial"/>
+                <a:cs typeface="Arial"/>
+              </a:defRPr>
+            </a:lvl5pPr>
+            <a:lvl6pPr>
+              <a:defRPr sz="1875" b="0">
+                <a:solidFill>
+                  <a:srgbClr val="17202B"/>
+                </a:solidFill>
+                <a:latin typeface="Arial"/>
+                <a:ea typeface="Arial"/>
+                <a:cs typeface="Arial"/>
+              </a:defRPr>
+            </a:lvl6pPr>
+            <a:lvl7pPr>
+              <a:defRPr sz="1875" b="0">
+                <a:solidFill>
+                  <a:srgbClr val="17202B"/>
+                </a:solidFill>
+                <a:latin typeface="Arial"/>
+                <a:ea typeface="Arial"/>
+                <a:cs typeface="Arial"/>
+              </a:defRPr>
+            </a:lvl7pPr>
+            <a:lvl8pPr>
+              <a:defRPr sz="1875" b="0">
+                <a:solidFill>
+                  <a:srgbClr val="17202B"/>
+                </a:solidFill>
+                <a:latin typeface="Arial"/>
+                <a:ea typeface="Arial"/>
+                <a:cs typeface="Arial"/>
+              </a:defRPr>
+            </a:lvl8pPr>
+            <a:lvl9pPr>
+              <a:defRPr sz="1875" b="0">
+                <a:solidFill>
+                  <a:srgbClr val="17202B"/>
+                </a:solidFill>
+                <a:latin typeface="Arial"/>
+                <a:ea typeface="Arial"/>
+                <a:cs typeface="Arial"/>
+              </a:defRPr>
+            </a:lvl9pPr>
+          </a:lstStyle>
+          <a:p xmlns:a="http://schemas.openxmlformats.org/drawingml/2006/main">
+            <a:pPr>
+              <a:defRPr sz="1875" b="0">
+                <a:solidFill>
+                  <a:srgbClr val="17202B"/>
+                </a:solidFill>
+                <a:latin typeface="Arial"/>
+                <a:ea typeface="Arial"/>
+                <a:cs typeface="Arial"/>
+              </a:defRPr>
+            </a:pPr>
+            <a:r>
+              <a:rPr sz="1875" b="0">
+                <a:solidFill>
+                  <a:srgbClr val="17202B"/>
+                </a:solidFill>
+                <a:latin typeface="Arial"/>
+                <a:ea typeface="Arial"/>
+                <a:cs typeface="Arial"/>
+              </a:rPr>
+              <a:t>ProjectPulse organizes tasks and working time for a fictional small-business website launch. This may support productive business activity, but the sample measures no employment, wages, or job quality.</a:t>
+            </a:r>
+          </a:p>
+        </p:txBody>
+      </p:sp>
+      <p:sp>
+        <p:nvSpPr>
+          <p:cNvPr id="7" name="">
+            <a:extLst xmlns:a="http://schemas.openxmlformats.org/drawingml/2006/main">
+              <a:ext uri="{FF2B5EF4-FFF2-40B4-BE49-F238E27FC236}">
+                <a16:creationId xmlns:a16="http://schemas.microsoft.com/office/drawing/2014/main" id="{8E7EE522-D656-4226-822D-D59D3EDE318E}"/>
+              </a:ext>
+            </a:extLst>
+          </p:cNvPr>
+          <p:cNvSpPr>
+            <a:spLocks xmlns:a="http://schemas.openxmlformats.org/drawingml/2006/main" noGrp="1"/>
+          </p:cNvSpPr>
+          <p:nvPr/>
+        </p:nvSpPr>
+        <p:spPr>
+          <a:xfrm xmlns:a="http://schemas.openxmlformats.org/drawingml/2006/main">
+            <a:off x="6334125" y="1952625"/>
+            <a:ext cx="4476750" cy="685800"/>
+          </a:xfrm>
+          <a:prstGeom xmlns:a="http://schemas.openxmlformats.org/drawingml/2006/main" prst="rect">
+            <a:avLst/>
+          </a:prstGeom>
+          <a:noFill xmlns:a="http://schemas.openxmlformats.org/drawingml/2006/main"/>
+          <a:ln xmlns:a="http://schemas.openxmlformats.org/drawingml/2006/main" w="0">
+            <a:noFill/>
+          </a:ln>
+        </p:spPr>
+        <p:txBody>
+          <a:bodyPr xmlns:a="http://schemas.openxmlformats.org/drawingml/2006/main"/>
+          <a:lstStyle xmlns:a="http://schemas.openxmlformats.org/drawingml/2006/main">
+            <a:defPPr>
+              <a:defRPr sz="4200" b="1">
+                <a:solidFill>
+                  <a:srgbClr val="006EDB"/>
+                </a:solidFill>
+                <a:latin typeface="Arial"/>
+                <a:ea typeface="Arial"/>
+                <a:cs typeface="Arial"/>
+              </a:defRPr>
+            </a:defPPr>
+            <a:lvl1pPr>
+              <a:defRPr sz="4200" b="1">
+                <a:solidFill>
+                  <a:srgbClr val="006EDB"/>
+                </a:solidFill>
+                <a:latin typeface="Arial"/>
+                <a:ea typeface="Arial"/>
+                <a:cs typeface="Arial"/>
+              </a:defRPr>
+            </a:lvl1pPr>
+            <a:lvl2pPr>
+              <a:defRPr sz="4200" b="1">
+                <a:solidFill>
+                  <a:srgbClr val="006EDB"/>
+                </a:solidFill>
+                <a:latin typeface="Arial"/>
+                <a:ea typeface="Arial"/>
+                <a:cs typeface="Arial"/>
+              </a:defRPr>
+            </a:lvl2pPr>
+            <a:lvl3pPr>
+              <a:defRPr sz="4200" b="1">
+                <a:solidFill>
+                  <a:srgbClr val="006EDB"/>
+                </a:solidFill>
+                <a:latin typeface="Arial"/>
+                <a:ea typeface="Arial"/>
+                <a:cs typeface="Arial"/>
+              </a:defRPr>
+            </a:lvl3pPr>
+            <a:lvl4pPr>
+              <a:defRPr sz="4200" b="1">
+                <a:solidFill>
+                  <a:srgbClr val="006EDB"/>
+                </a:solidFill>
+                <a:latin typeface="Arial"/>
+                <a:ea typeface="Arial"/>
+                <a:cs typeface="Arial"/>
+              </a:defRPr>
+            </a:lvl4pPr>
+            <a:lvl5pPr>
+              <a:defRPr sz="4200" b="1">
+                <a:solidFill>
+                  <a:srgbClr val="006EDB"/>
+                </a:solidFill>
+                <a:latin typeface="Arial"/>
+                <a:ea typeface="Arial"/>
+                <a:cs typeface="Arial"/>
+              </a:defRPr>
+            </a:lvl5pPr>
+            <a:lvl6pPr>
+              <a:defRPr sz="4200" b="1">
+                <a:solidFill>
+                  <a:srgbClr val="006EDB"/>
+                </a:solidFill>
+                <a:latin typeface="Arial"/>
+                <a:ea typeface="Arial"/>
+                <a:cs typeface="Arial"/>
+              </a:defRPr>
+            </a:lvl6pPr>
+            <a:lvl7pPr>
+              <a:defRPr sz="4200" b="1">
+                <a:solidFill>
+                  <a:srgbClr val="006EDB"/>
+                </a:solidFill>
+                <a:latin typeface="Arial"/>
+                <a:ea typeface="Arial"/>
+                <a:cs typeface="Arial"/>
+              </a:defRPr>
+            </a:lvl7pPr>
+            <a:lvl8pPr>
+              <a:defRPr sz="4200" b="1">
+                <a:solidFill>
+                  <a:srgbClr val="006EDB"/>
+                </a:solidFill>
+                <a:latin typeface="Arial"/>
+                <a:ea typeface="Arial"/>
+                <a:cs typeface="Arial"/>
+              </a:defRPr>
+            </a:lvl8pPr>
+            <a:lvl9pPr>
+              <a:defRPr sz="4200" b="1">
+                <a:solidFill>
+                  <a:srgbClr val="006EDB"/>
+                </a:solidFill>
+                <a:latin typeface="Arial"/>
+                <a:ea typeface="Arial"/>
+                <a:cs typeface="Arial"/>
+              </a:defRPr>
+            </a:lvl9pPr>
+          </a:lstStyle>
+          <a:p xmlns:a="http://schemas.openxmlformats.org/drawingml/2006/main">
+            <a:pPr>
+              <a:defRPr sz="4200" b="1">
+                <a:solidFill>
+                  <a:srgbClr val="006EDB"/>
+                </a:solidFill>
+                <a:latin typeface="Arial"/>
+                <a:ea typeface="Arial"/>
+                <a:cs typeface="Arial"/>
+              </a:defRPr>
+            </a:pPr>
+            <a:r>
+              <a:rPr sz="4200" b="1">
+                <a:solidFill>
+                  <a:srgbClr val="006EDB"/>
+                </a:solidFill>
+                <a:latin typeface="Arial"/>
+                <a:ea typeface="Arial"/>
+                <a:cs typeface="Arial"/>
+              </a:rPr>
+              <a:t>GOAL 9</a:t>
+            </a:r>
+          </a:p>
+        </p:txBody>
+      </p:sp>
+      <p:sp>
+        <p:nvSpPr>
+          <p:cNvPr id="8" name="">
+            <a:extLst xmlns:a="http://schemas.openxmlformats.org/drawingml/2006/main">
+              <a:ext uri="{FF2B5EF4-FFF2-40B4-BE49-F238E27FC236}">
+                <a16:creationId xmlns:a16="http://schemas.microsoft.com/office/drawing/2014/main" id="{DA0DD3D0-06B4-43D7-8D60-57000280F34A}"/>
+              </a:ext>
+            </a:extLst>
+          </p:cNvPr>
+          <p:cNvSpPr>
+            <a:spLocks xmlns:a="http://schemas.openxmlformats.org/drawingml/2006/main" noGrp="1"/>
+          </p:cNvSpPr>
+          <p:nvPr/>
+        </p:nvSpPr>
+        <p:spPr>
+          <a:xfrm xmlns:a="http://schemas.openxmlformats.org/drawingml/2006/main">
+            <a:off x="6334125" y="2686050"/>
+            <a:ext cx="5048250" cy="714375"/>
+          </a:xfrm>
+          <a:prstGeom xmlns:a="http://schemas.openxmlformats.org/drawingml/2006/main" prst="rect">
+            <a:avLst/>
+          </a:prstGeom>
+          <a:noFill xmlns:a="http://schemas.openxmlformats.org/drawingml/2006/main"/>
+          <a:ln xmlns:a="http://schemas.openxmlformats.org/drawingml/2006/main" w="0">
+            <a:noFill/>
+          </a:ln>
+        </p:spPr>
+        <p:txBody>
+          <a:bodyPr xmlns:a="http://schemas.openxmlformats.org/drawingml/2006/main"/>
+          <a:lstStyle xmlns:a="http://schemas.openxmlformats.org/drawingml/2006/main">
+            <a:defPPr>
+              <a:defRPr sz="2250" b="1">
+                <a:solidFill>
+                  <a:srgbClr val="17202B"/>
+                </a:solidFill>
+                <a:latin typeface="Arial"/>
+                <a:ea typeface="Arial"/>
+                <a:cs typeface="Arial"/>
+              </a:defRPr>
+            </a:defPPr>
+            <a:lvl1pPr>
+              <a:defRPr sz="2250" b="1">
+                <a:solidFill>
+                  <a:srgbClr val="17202B"/>
+                </a:solidFill>
+                <a:latin typeface="Arial"/>
+                <a:ea typeface="Arial"/>
+                <a:cs typeface="Arial"/>
+              </a:defRPr>
+            </a:lvl1pPr>
+            <a:lvl2pPr>
+              <a:defRPr sz="2250" b="1">
+                <a:solidFill>
+                  <a:srgbClr val="17202B"/>
+                </a:solidFill>
+                <a:latin typeface="Arial"/>
+                <a:ea typeface="Arial"/>
+                <a:cs typeface="Arial"/>
+              </a:defRPr>
+            </a:lvl2pPr>
+            <a:lvl3pPr>
+              <a:defRPr sz="2250" b="1">
+                <a:solidFill>
+                  <a:srgbClr val="17202B"/>
+                </a:solidFill>
+                <a:latin typeface="Arial"/>
+                <a:ea typeface="Arial"/>
+                <a:cs typeface="Arial"/>
+              </a:defRPr>
+            </a:lvl3pPr>
+            <a:lvl4pPr>
+              <a:defRPr sz="2250" b="1">
+                <a:solidFill>
+                  <a:srgbClr val="17202B"/>
+                </a:solidFill>
+                <a:latin typeface="Arial"/>
+                <a:ea typeface="Arial"/>
+                <a:cs typeface="Arial"/>
+              </a:defRPr>
+            </a:lvl4pPr>
+            <a:lvl5pPr>
+              <a:defRPr sz="2250" b="1">
+                <a:solidFill>
+                  <a:srgbClr val="17202B"/>
+                </a:solidFill>
+                <a:latin typeface="Arial"/>
+                <a:ea typeface="Arial"/>
+                <a:cs typeface="Arial"/>
+              </a:defRPr>
+            </a:lvl5pPr>
+            <a:lvl6pPr>
+              <a:defRPr sz="2250" b="1">
+                <a:solidFill>
+                  <a:srgbClr val="17202B"/>
+                </a:solidFill>
+                <a:latin typeface="Arial"/>
+                <a:ea typeface="Arial"/>
+                <a:cs typeface="Arial"/>
+              </a:defRPr>
+            </a:lvl6pPr>
+            <a:lvl7pPr>
+              <a:defRPr sz="2250" b="1">
+                <a:solidFill>
+                  <a:srgbClr val="17202B"/>
+                </a:solidFill>
+                <a:latin typeface="Arial"/>
+                <a:ea typeface="Arial"/>
+                <a:cs typeface="Arial"/>
+              </a:defRPr>
+            </a:lvl7pPr>
+            <a:lvl8pPr>
+              <a:defRPr sz="2250" b="1">
+                <a:solidFill>
+                  <a:srgbClr val="17202B"/>
+                </a:solidFill>
+                <a:latin typeface="Arial"/>
+                <a:ea typeface="Arial"/>
+                <a:cs typeface="Arial"/>
+              </a:defRPr>
+            </a:lvl8pPr>
+            <a:lvl9pPr>
+              <a:defRPr sz="2250" b="1">
+                <a:solidFill>
+                  <a:srgbClr val="17202B"/>
+                </a:solidFill>
+                <a:latin typeface="Arial"/>
+                <a:ea typeface="Arial"/>
+                <a:cs typeface="Arial"/>
+              </a:defRPr>
+            </a:lvl9pPr>
+          </a:lstStyle>
+          <a:p xmlns:a="http://schemas.openxmlformats.org/drawingml/2006/main">
+            <a:pPr>
+              <a:defRPr sz="2250" b="1">
+                <a:solidFill>
+                  <a:srgbClr val="17202B"/>
+                </a:solidFill>
+                <a:latin typeface="Arial"/>
+                <a:ea typeface="Arial"/>
+                <a:cs typeface="Arial"/>
+              </a:defRPr>
+            </a:pPr>
+            <a:r>
+              <a:rPr sz="2250" b="1">
+                <a:solidFill>
+                  <a:srgbClr val="17202B"/>
+                </a:solidFill>
+                <a:latin typeface="Arial"/>
+                <a:ea typeface="Arial"/>
+                <a:cs typeface="Arial"/>
+              </a:rPr>
+              <a:t>Industry, Innovation and Infrastructure</a:t>
+            </a:r>
+          </a:p>
+        </p:txBody>
+      </p:sp>
+      <p:sp>
+        <p:nvSpPr>
+          <p:cNvPr id="9" name="">
+            <a:extLst xmlns:a="http://schemas.openxmlformats.org/drawingml/2006/main">
+              <a:ext uri="{FF2B5EF4-FFF2-40B4-BE49-F238E27FC236}">
+                <a16:creationId xmlns:a16="http://schemas.microsoft.com/office/drawing/2014/main" id="{3C31FFBD-C088-4C6E-A608-83A3BBFFE833}"/>
+              </a:ext>
+            </a:extLst>
+          </p:cNvPr>
+          <p:cNvSpPr>
+            <a:spLocks xmlns:a="http://schemas.openxmlformats.org/drawingml/2006/main" noGrp="1"/>
+          </p:cNvSpPr>
+          <p:nvPr/>
+        </p:nvSpPr>
+        <p:spPr>
+          <a:xfrm xmlns:a="http://schemas.openxmlformats.org/drawingml/2006/main">
+            <a:off x="6334125" y="3638550"/>
+            <a:ext cx="4953000" cy="1762125"/>
+          </a:xfrm>
+          <a:prstGeom xmlns:a="http://schemas.openxmlformats.org/drawingml/2006/main" prst="rect">
+            <a:avLst/>
+          </a:prstGeom>
+          <a:noFill xmlns:a="http://schemas.openxmlformats.org/drawingml/2006/main"/>
+          <a:ln xmlns:a="http://schemas.openxmlformats.org/drawingml/2006/main" w="0">
+            <a:noFill/>
+          </a:ln>
+        </p:spPr>
+        <p:txBody>
+          <a:bodyPr xmlns:a="http://schemas.openxmlformats.org/drawingml/2006/main"/>
+          <a:lstStyle xmlns:a="http://schemas.openxmlformats.org/drawingml/2006/main">
+            <a:defPPr>
+              <a:defRPr sz="1875" b="0">
+                <a:solidFill>
+                  <a:srgbClr val="17202B"/>
+                </a:solidFill>
+                <a:latin typeface="Arial"/>
+                <a:ea typeface="Arial"/>
+                <a:cs typeface="Arial"/>
+              </a:defRPr>
+            </a:defPPr>
+            <a:lvl1pPr>
+              <a:defRPr sz="1875" b="0">
+                <a:solidFill>
+                  <a:srgbClr val="17202B"/>
+                </a:solidFill>
+                <a:latin typeface="Arial"/>
+                <a:ea typeface="Arial"/>
+                <a:cs typeface="Arial"/>
+              </a:defRPr>
+            </a:lvl1pPr>
+            <a:lvl2pPr>
+              <a:defRPr sz="1875" b="0">
+                <a:solidFill>
+                  <a:srgbClr val="17202B"/>
+                </a:solidFill>
+                <a:latin typeface="Arial"/>
+                <a:ea typeface="Arial"/>
+                <a:cs typeface="Arial"/>
+              </a:defRPr>
+            </a:lvl2pPr>
+            <a:lvl3pPr>
+              <a:defRPr sz="1875" b="0">
+                <a:solidFill>
+                  <a:srgbClr val="17202B"/>
+                </a:solidFill>
+                <a:latin typeface="Arial"/>
+                <a:ea typeface="Arial"/>
+                <a:cs typeface="Arial"/>
+              </a:defRPr>
+            </a:lvl3pPr>
+            <a:lvl4pPr>
+              <a:defRPr sz="1875" b="0">
+                <a:solidFill>
+                  <a:srgbClr val="17202B"/>
+                </a:solidFill>
+                <a:latin typeface="Arial"/>
+                <a:ea typeface="Arial"/>
+                <a:cs typeface="Arial"/>
+              </a:defRPr>
+            </a:lvl4pPr>
+            <a:lvl5pPr>
+              <a:defRPr sz="1875" b="0">
+                <a:solidFill>
+                  <a:srgbClr val="17202B"/>
+                </a:solidFill>
+                <a:latin typeface="Arial"/>
+                <a:ea typeface="Arial"/>
+                <a:cs typeface="Arial"/>
+              </a:defRPr>
+            </a:lvl5pPr>
+            <a:lvl6pPr>
+              <a:defRPr sz="1875" b="0">
+                <a:solidFill>
+                  <a:srgbClr val="17202B"/>
+                </a:solidFill>
+                <a:latin typeface="Arial"/>
+                <a:ea typeface="Arial"/>
+                <a:cs typeface="Arial"/>
+              </a:defRPr>
+            </a:lvl6pPr>
+            <a:lvl7pPr>
+              <a:defRPr sz="1875" b="0">
+                <a:solidFill>
+                  <a:srgbClr val="17202B"/>
+                </a:solidFill>
+                <a:latin typeface="Arial"/>
+                <a:ea typeface="Arial"/>
+                <a:cs typeface="Arial"/>
+              </a:defRPr>
+            </a:lvl7pPr>
+            <a:lvl8pPr>
+              <a:defRPr sz="1875" b="0">
+                <a:solidFill>
+                  <a:srgbClr val="17202B"/>
+                </a:solidFill>
+                <a:latin typeface="Arial"/>
+                <a:ea typeface="Arial"/>
+                <a:cs typeface="Arial"/>
+              </a:defRPr>
+            </a:lvl8pPr>
+            <a:lvl9pPr>
+              <a:defRPr sz="1875" b="0">
+                <a:solidFill>
+                  <a:srgbClr val="17202B"/>
+                </a:solidFill>
+                <a:latin typeface="Arial"/>
+                <a:ea typeface="Arial"/>
+                <a:cs typeface="Arial"/>
+              </a:defRPr>
+            </a:lvl9pPr>
+          </a:lstStyle>
+          <a:p xmlns:a="http://schemas.openxmlformats.org/drawingml/2006/main">
+            <a:pPr>
+              <a:defRPr sz="1875" b="0">
+                <a:solidFill>
+                  <a:srgbClr val="17202B"/>
+                </a:solidFill>
+                <a:latin typeface="Arial"/>
+                <a:ea typeface="Arial"/>
+                <a:cs typeface="Arial"/>
+              </a:defRPr>
+            </a:pPr>
+            <a:r>
+              <a:rPr sz="1875" b="0">
+                <a:solidFill>
+                  <a:srgbClr val="17202B"/>
+                </a:solidFill>
+                <a:latin typeface="Arial"/>
+                <a:ea typeface="Arial"/>
+                <a:cs typeface="Arial"/>
+              </a:rPr>
+              <a:t>The app is a digital planning tool used to organize project work, connecting it to Goal 9’s innovation theme. It measures no wider infrastructure access or industry outcomes.</a:t>
+            </a:r>
+          </a:p>
+        </p:txBody>
+      </p:sp>
+      <p:sp>
+        <p:nvSpPr>
+          <p:cNvPr id="10" name="">
+            <a:extLst xmlns:a="http://schemas.openxmlformats.org/drawingml/2006/main">
+              <a:ext uri="{FF2B5EF4-FFF2-40B4-BE49-F238E27FC236}">
+                <a16:creationId xmlns:a16="http://schemas.microsoft.com/office/drawing/2014/main" id="{3089558B-1570-4AD4-80CD-11705BAFF124}"/>
+              </a:ext>
+            </a:extLst>
+          </p:cNvPr>
+          <p:cNvSpPr>
+            <a:spLocks xmlns:a="http://schemas.openxmlformats.org/drawingml/2006/main" noGrp="1"/>
+          </p:cNvSpPr>
+          <p:nvPr/>
+        </p:nvSpPr>
+        <p:spPr>
+          <a:xfrm xmlns:a="http://schemas.openxmlformats.org/drawingml/2006/main">
+            <a:off x="685800" y="5619750"/>
+            <a:ext cx="10477500" cy="476250"/>
+          </a:xfrm>
+          <a:prstGeom xmlns:a="http://schemas.openxmlformats.org/drawingml/2006/main" prst="rect">
+            <a:avLst/>
+          </a:prstGeom>
+          <a:noFill xmlns:a="http://schemas.openxmlformats.org/drawingml/2006/main"/>
+          <a:ln xmlns:a="http://schemas.openxmlformats.org/drawingml/2006/main" w="0">
+            <a:noFill/>
+          </a:ln>
+        </p:spPr>
+        <p:txBody>
+          <a:bodyPr xmlns:a="http://schemas.openxmlformats.org/drawingml/2006/main"/>
+          <a:lstStyle xmlns:a="http://schemas.openxmlformats.org/drawingml/2006/main">
+            <a:defPPr>
+              <a:defRPr sz="1800" b="0">
+                <a:solidFill>
+                  <a:srgbClr val="596574"/>
+                </a:solidFill>
+                <a:latin typeface="Arial"/>
+                <a:ea typeface="Arial"/>
+                <a:cs typeface="Arial"/>
+              </a:defRPr>
+            </a:defPPr>
+            <a:lvl1pPr>
+              <a:defRPr sz="1800" b="0">
+                <a:solidFill>
+                  <a:srgbClr val="596574"/>
+                </a:solidFill>
+                <a:latin typeface="Arial"/>
+                <a:ea typeface="Arial"/>
+                <a:cs typeface="Arial"/>
+              </a:defRPr>
+            </a:lvl1pPr>
+            <a:lvl2pPr>
+              <a:defRPr sz="1800" b="0">
+                <a:solidFill>
+                  <a:srgbClr val="596574"/>
+                </a:solidFill>
+                <a:latin typeface="Arial"/>
+                <a:ea typeface="Arial"/>
+                <a:cs typeface="Arial"/>
+              </a:defRPr>
+            </a:lvl2pPr>
+            <a:lvl3pPr>
+              <a:defRPr sz="1800" b="0">
+                <a:solidFill>
+                  <a:srgbClr val="596574"/>
+                </a:solidFill>
+                <a:latin typeface="Arial"/>
+                <a:ea typeface="Arial"/>
+                <a:cs typeface="Arial"/>
+              </a:defRPr>
+            </a:lvl3pPr>
+            <a:lvl4pPr>
+              <a:defRPr sz="1800" b="0">
+                <a:solidFill>
+                  <a:srgbClr val="596574"/>
+                </a:solidFill>
+                <a:latin typeface="Arial"/>
+                <a:ea typeface="Arial"/>
+                <a:cs typeface="Arial"/>
+              </a:defRPr>
+            </a:lvl4pPr>
+            <a:lvl5pPr>
+              <a:defRPr sz="1800" b="0">
+                <a:solidFill>
+                  <a:srgbClr val="596574"/>
+                </a:solidFill>
+                <a:latin typeface="Arial"/>
+                <a:ea typeface="Arial"/>
+                <a:cs typeface="Arial"/>
+              </a:defRPr>
+            </a:lvl5pPr>
+            <a:lvl6pPr>
+              <a:defRPr sz="1800" b="0">
+                <a:solidFill>
+                  <a:srgbClr val="596574"/>
+                </a:solidFill>
+                <a:latin typeface="Arial"/>
+                <a:ea typeface="Arial"/>
+                <a:cs typeface="Arial"/>
+              </a:defRPr>
+            </a:lvl6pPr>
+            <a:lvl7pPr>
+              <a:defRPr sz="1800" b="0">
+                <a:solidFill>
+                  <a:srgbClr val="596574"/>
+                </a:solidFill>
+                <a:latin typeface="Arial"/>
+                <a:ea typeface="Arial"/>
+                <a:cs typeface="Arial"/>
+              </a:defRPr>
+            </a:lvl7pPr>
+            <a:lvl8pPr>
+              <a:defRPr sz="1800" b="0">
+                <a:solidFill>
+                  <a:srgbClr val="596574"/>
+                </a:solidFill>
+                <a:latin typeface="Arial"/>
+                <a:ea typeface="Arial"/>
+                <a:cs typeface="Arial"/>
+              </a:defRPr>
+            </a:lvl8pPr>
+            <a:lvl9pPr>
+              <a:defRPr sz="1800" b="0">
+                <a:solidFill>
+                  <a:srgbClr val="596574"/>
+                </a:solidFill>
+                <a:latin typeface="Arial"/>
+                <a:ea typeface="Arial"/>
+                <a:cs typeface="Arial"/>
+              </a:defRPr>
+            </a:lvl9pPr>
+          </a:lstStyle>
+          <a:p xmlns:a="http://schemas.openxmlformats.org/drawingml/2006/main">
+            <a:pPr>
+              <a:defRPr sz="1800" b="0">
+                <a:solidFill>
+                  <a:srgbClr val="596574"/>
+                </a:solidFill>
+                <a:latin typeface="Arial"/>
+                <a:ea typeface="Arial"/>
+                <a:cs typeface="Arial"/>
+              </a:defRPr>
+            </a:pPr>
+            <a:r>
+              <a:rPr sz="1800" b="0">
+                <a:solidFill>
+                  <a:srgbClr val="596574"/>
+                </a:solidFill>
+                <a:latin typeface="Arial"/>
+                <a:ea typeface="Arial"/>
+                <a:cs typeface="Arial"/>
+              </a:rPr>
+              <a:t>These are areas of possible alignment, not measured SDG impact.</a:t>
+            </a:r>
+          </a:p>
+        </p:txBody>
+      </p:sp>
+    </p:spTree>
+    <p:extLst>
+      <p:ext uri="{BB962C8B-B14F-4D97-AF65-F5344CB8AC3E}">
+        <p14:creationId xmlns:p14="http://schemas.microsoft.com/office/powerpoint/2010/main" val="256932003"/>
+      </p:ext>
+    </p:extLst>
+  </p:cSld>
+</p:sld>
+</file>
+
+<file path=ppt/slides/slide13.xml><?xml version="1.0" encoding="utf-8"?>
+<p:sld xmlns:p="http://schemas.openxmlformats.org/presentationml/2006/main">
+  <p:cSld>
+    <p:bg>
+      <p:bgPr>
+        <a:solidFill xmlns:a="http://schemas.openxmlformats.org/drawingml/2006/main">
+          <a:srgbClr val="F5F6F8"/>
+        </a:solidFill>
+      </p:bgPr>
+    </p:bg>
+    <p:spTree>
+      <p:nvGrpSpPr>
+        <p:cNvPr id="1" name=""/>
+        <p:cNvGrpSpPr/>
+        <p:nvPr/>
+      </p:nvGrpSpPr>
+      <p:grpSpPr>
+        <a:xfrm xmlns:a="http://schemas.openxmlformats.org/drawingml/2006/main"/>
+      </p:grpSpPr>
+      <p:sp>
+        <p:nvSpPr>
+          <p:cNvPr id="2" name="">
+            <a:extLst xmlns:a="http://schemas.openxmlformats.org/drawingml/2006/main">
+              <a:ext uri="{FF2B5EF4-FFF2-40B4-BE49-F238E27FC236}">
                 <a16:creationId xmlns:a16="http://schemas.microsoft.com/office/drawing/2014/main" id="{4C7DD72E-B963-4113-8E69-503BCE26D12F}"/>
               </a:ext>
             </a:extLst>
@@ -8259,7 +9763,7 @@
                 <a:ea typeface="Arial"/>
                 <a:cs typeface="Arial"/>
               </a:rPr>
-              <a:t>12</a:t>
+              <a:t>13</a:t>
             </a:r>
           </a:p>
         </p:txBody>
@@ -9210,7 +10714,7 @@
 </p:sld>
 </file>
 
-<file path=ppt/slides/slide13.xml><?xml version="1.0" encoding="utf-8"?>
+<file path=ppt/slides/slide14.xml><?xml version="1.0" encoding="utf-8"?>
 <p:sld xmlns:p="http://schemas.openxmlformats.org/presentationml/2006/main">
   <p:cSld>
     <p:bg>
@@ -9536,7 +11040,7 @@
                 <a:ea typeface="Arial"/>
                 <a:cs typeface="Arial"/>
               </a:rPr>
-              <a:t>13</a:t>
+              <a:t>14</a:t>
             </a:r>
           </a:p>
         </p:txBody>
@@ -10510,7 +12014,7 @@
 </p:sld>
 </file>
 
-<file path=ppt/slides/slide14.xml><?xml version="1.0" encoding="utf-8"?>
+<file path=ppt/slides/slide15.xml><?xml version="1.0" encoding="utf-8"?>
 <p:sld xmlns:p="http://schemas.openxmlformats.org/presentationml/2006/main">
   <p:cSld>
     <p:bg>
@@ -10836,7 +12340,7 @@
                 <a:ea typeface="Arial"/>
                 <a:cs typeface="Arial"/>
               </a:rPr>
-              <a:t>14</a:t>
+              <a:t>15</a:t>
             </a:r>
           </a:p>
         </p:txBody>
@@ -15918,7 +17422,7 @@
           <p:nvPr/>
         </p:nvPicPr>
         <p:blipFill>
-          <a:blip xmlns:r="http://schemas.openxmlformats.org/officeDocument/2006/relationships" xmlns:a="http://schemas.openxmlformats.org/drawingml/2006/main" r:embed="Rfcc8cb04eb9f479c"/>
+          <a:blip xmlns:r="http://schemas.openxmlformats.org/officeDocument/2006/relationships" xmlns:a="http://schemas.openxmlformats.org/drawingml/2006/main" r:embed="R435337782a8340fb"/>
           <a:stretch xmlns:a="http://schemas.openxmlformats.org/drawingml/2006/main"/>
         </p:blipFill>
         <p:spPr>
@@ -17223,7 +18727,7 @@
           <p:nvPr/>
         </p:nvPicPr>
         <p:blipFill>
-          <a:blip xmlns:r="http://schemas.openxmlformats.org/officeDocument/2006/relationships" xmlns:a="http://schemas.openxmlformats.org/drawingml/2006/main" r:embed="R5485462b4e8242d0"/>
+          <a:blip xmlns:r="http://schemas.openxmlformats.org/officeDocument/2006/relationships" xmlns:a="http://schemas.openxmlformats.org/drawingml/2006/main" r:embed="R930f375fe34d4a0f"/>
           <a:stretch xmlns:a="http://schemas.openxmlformats.org/drawingml/2006/main"/>
         </p:blipFill>
         <p:spPr>
@@ -19303,7 +20807,7 @@
           <p:nvPr/>
         </p:nvPicPr>
         <p:blipFill>
-          <a:blip xmlns:r="http://schemas.openxmlformats.org/officeDocument/2006/relationships" xmlns:a="http://schemas.openxmlformats.org/drawingml/2006/main" r:embed="R4c932622ea77456c"/>
+          <a:blip xmlns:r="http://schemas.openxmlformats.org/officeDocument/2006/relationships" xmlns:a="http://schemas.openxmlformats.org/drawingml/2006/main" r:embed="Ree29243274054137"/>
           <a:stretch xmlns:a="http://schemas.openxmlformats.org/drawingml/2006/main"/>
         </p:blipFill>
         <p:spPr>
@@ -20296,7 +21800,7 @@
           <p:nvPr/>
         </p:nvPicPr>
         <p:blipFill>
-          <a:blip xmlns:r="http://schemas.openxmlformats.org/officeDocument/2006/relationships" xmlns:a="http://schemas.openxmlformats.org/drawingml/2006/main" r:embed="Rf6380cbdbe554ec0"/>
+          <a:blip xmlns:r="http://schemas.openxmlformats.org/officeDocument/2006/relationships" xmlns:a="http://schemas.openxmlformats.org/drawingml/2006/main" r:embed="R493bf822bb4f447e"/>
           <a:stretch xmlns:a="http://schemas.openxmlformats.org/drawingml/2006/main"/>
         </p:blipFill>
         <p:spPr>

</xml_diff>